<commit_message>
feat: add core functionality for programmatic PPTX generation and a new CLI.
</commit_message>
<xml_diff>
--- a/smoke_samples/01_basic_pptx.pptx
+++ b/smoke_samples/01_basic_pptx.pptx
@@ -229,7 +229,7 @@
         <p:spPr>
           <a:xfrm>
             <a:off x="457200" y="274638"/>
-            <a:ext cx="8230200" cy="1143000"/>
+            <a:ext cx="8229600" cy="1143000"/>
           </a:xfrm>
           <a:prstGeom prst="rect">
             <a:avLst/>
@@ -242,7 +242,7 @@
           <a:p>
             <a:pPr algn="l"/>
             <a:r>
-              <a:rPr lang="en-US" sz="4400" b="1" i="0" dirty="0"/>
+              <a:rPr lang="en-US" sz="4400" b="0" i="0" u="none" dirty="0"/>
               <a:t>Basic PPTX Generation</a:t>
             </a:r>
           </a:p>
@@ -257,7 +257,7 @@
         <p:spPr>
           <a:xfrm>
             <a:off x="457200" y="1600200"/>
-            <a:ext cx="8230200" cy="4572000"/>
+            <a:ext cx="8229600" cy="4572000"/>
           </a:xfrm>
           <a:prstGeom prst="rect">
             <a:avLst/>
@@ -272,7 +272,7 @@
               <a:buChar char="•"/>
             </a:pPr>
             <a:r>
-              <a:rPr lang="en-US" sz="2800" b="0" i="0" dirty="0"/>
+              <a:rPr lang="en-US" sz="2800" b="0" i="0" u="none" dirty="0"/>
               <a:t>Simple slide creation</a:t>
             </a:r>
           </a:p>
@@ -281,7 +281,7 @@
               <a:buChar char="•"/>
             </a:pPr>
             <a:r>
-              <a:rPr lang="en-US" sz="2800" b="0" i="0" dirty="0"/>
+              <a:rPr lang="en-US" sz="2800" b="0" i="0" u="none" dirty="0"/>
               <a:t>Title and bullet points</a:t>
             </a:r>
           </a:p>
@@ -290,7 +290,7 @@
               <a:buChar char="•"/>
             </a:pPr>
             <a:r>
-              <a:rPr lang="en-US" sz="2800" b="0" i="0" dirty="0"/>
+              <a:rPr lang="en-US" sz="2800" b="0" i="0" u="none" dirty="0"/>
               <a:t>Task 01 complete</a:t>
             </a:r>
           </a:p>

</xml_diff>

<commit_message>
feat: Add Go scripts for generating diverse PPTX smoke samples and introduce new slide and content element handling.
</commit_message>
<xml_diff>
--- a/smoke_samples/01_basic_pptx.pptx
+++ b/smoke_samples/01_basic_pptx.pptx
@@ -265,14 +265,14 @@
           <a:noFill/>
         </p:spPr>
         <p:txBody>
-          <a:bodyPr wrap="square" rtlCol="0"/>
+          <a:bodyPr wrap="square" rtlCol="0" anchor="t"/>
           <a:lstStyle/>
           <a:p>
             <a:pPr lvl="0" marL="457200" indent="-457200">
               <a:buChar char="•"/>
             </a:pPr>
             <a:r>
-              <a:rPr lang="en-US" sz="2800" b="0" i="0" u="none" dirty="0"/>
+              <a:rPr lang="en-US" sz="1800" b="0" i="0" u="none" dirty="0"/>
               <a:t>Simple slide creation</a:t>
             </a:r>
           </a:p>
@@ -281,7 +281,7 @@
               <a:buChar char="•"/>
             </a:pPr>
             <a:r>
-              <a:rPr lang="en-US" sz="2800" b="0" i="0" u="none" dirty="0"/>
+              <a:rPr lang="en-US" sz="1800" b="0" i="0" u="none" dirty="0"/>
               <a:t>Title and bullet points</a:t>
             </a:r>
           </a:p>
@@ -290,7 +290,7 @@
               <a:buChar char="•"/>
             </a:pPr>
             <a:r>
-              <a:rPr lang="en-US" sz="2800" b="0" i="0" u="none" dirty="0"/>
+              <a:rPr lang="en-US" sz="1800" b="0" i="0" u="none" dirty="0"/>
               <a:t>Task 01 complete</a:t>
             </a:r>
           </a:p>

</xml_diff>

<commit_message>
feat: Introduce initial PPTX editor functionality, including core presentation parsing, element management, and comprehensive smoke samples.
</commit_message>
<xml_diff>
--- a/smoke_samples/01_basic_pptx.pptx
+++ b/smoke_samples/01_basic_pptx.pptx
@@ -201,11 +201,6 @@
 <file path=ppt/slides/slide1.xml><?xml version="1.0" encoding="utf-8"?>
 <p:sld xmlns:a="http://schemas.openxmlformats.org/drawingml/2006/main" xmlns:c="http://schemas.openxmlformats.org/drawingml/2006/chart" xmlns:r="http://schemas.openxmlformats.org/officeDocument/2006/relationships" xmlns:p="http://schemas.openxmlformats.org/presentationml/2006/main">
   <p:cSld>
-    <p:bg>
-      <p:bgRef idx="1001">
-        <a:schemeClr val="bg1"/>
-      </p:bgRef>
-    </p:bg>
     <p:spTree>
       <p:nvGrpSpPr>
         <p:cNvPr id="1" name=""/>
@@ -305,9 +300,9 @@
 </file>
 
 <file path=ppt/theme/theme1.xml><?xml version="1.0" encoding="utf-8"?>
-<a:theme xmlns:a="http://schemas.openxmlformats.org/drawingml/2006/main" name="Office Theme">
+<a:theme xmlns:a="http://schemas.openxmlformats.org/drawingml/2006/main" name="Office Theme marketing">
   <a:themeElements>
-    <a:clrScheme name="Office">
+    <a:clrScheme name="Office colors">
       <a:dk1>
         <a:sysClr val="windowText" lastClr="000000"/>
       </a:dk1>
@@ -345,7 +340,7 @@
         <a:srgbClr val="800080"/>
       </a:folHlink>
     </a:clrScheme>
-    <a:fontScheme name="Office">
+    <a:fontScheme name="Office fonts">
       <a:majorFont>
         <a:latin typeface="Calibri"/>
         <a:ea typeface=""/>

</xml_diff>